<commit_message>
minor tweaks to the figure in response to https://github.com/MODFLOW-ORG/modflow6/pull/2674#pullrequestreview-3729364737
</commit_message>
<xml_diff>
--- a/doc/mf6io/Figures/lak-et-rch-depiction.pptx
+++ b/doc/mf6io/Figures/lak-et-rch-depiction.pptx
@@ -243,7 +243,7 @@
           <a:p>
             <a:fld id="{2A54808E-8DB4-4493-9A61-38B306C64F33}" type="datetimeFigureOut">
               <a:rPr lang="en-US" smtClean="0"/>
-              <a:t>1/29/2026</a:t>
+              <a:t>1/30/2026</a:t>
             </a:fld>
             <a:endParaRPr lang="en-US"/>
           </a:p>
@@ -413,7 +413,7 @@
           <a:p>
             <a:fld id="{2A54808E-8DB4-4493-9A61-38B306C64F33}" type="datetimeFigureOut">
               <a:rPr lang="en-US" smtClean="0"/>
-              <a:t>1/29/2026</a:t>
+              <a:t>1/30/2026</a:t>
             </a:fld>
             <a:endParaRPr lang="en-US"/>
           </a:p>
@@ -593,7 +593,7 @@
           <a:p>
             <a:fld id="{2A54808E-8DB4-4493-9A61-38B306C64F33}" type="datetimeFigureOut">
               <a:rPr lang="en-US" smtClean="0"/>
-              <a:t>1/29/2026</a:t>
+              <a:t>1/30/2026</a:t>
             </a:fld>
             <a:endParaRPr lang="en-US"/>
           </a:p>
@@ -763,7 +763,7 @@
           <a:p>
             <a:fld id="{2A54808E-8DB4-4493-9A61-38B306C64F33}" type="datetimeFigureOut">
               <a:rPr lang="en-US" smtClean="0"/>
-              <a:t>1/29/2026</a:t>
+              <a:t>1/30/2026</a:t>
             </a:fld>
             <a:endParaRPr lang="en-US"/>
           </a:p>
@@ -1009,7 +1009,7 @@
           <a:p>
             <a:fld id="{2A54808E-8DB4-4493-9A61-38B306C64F33}" type="datetimeFigureOut">
               <a:rPr lang="en-US" smtClean="0"/>
-              <a:t>1/29/2026</a:t>
+              <a:t>1/30/2026</a:t>
             </a:fld>
             <a:endParaRPr lang="en-US"/>
           </a:p>
@@ -1241,7 +1241,7 @@
           <a:p>
             <a:fld id="{2A54808E-8DB4-4493-9A61-38B306C64F33}" type="datetimeFigureOut">
               <a:rPr lang="en-US" smtClean="0"/>
-              <a:t>1/29/2026</a:t>
+              <a:t>1/30/2026</a:t>
             </a:fld>
             <a:endParaRPr lang="en-US"/>
           </a:p>
@@ -1608,7 +1608,7 @@
           <a:p>
             <a:fld id="{2A54808E-8DB4-4493-9A61-38B306C64F33}" type="datetimeFigureOut">
               <a:rPr lang="en-US" smtClean="0"/>
-              <a:t>1/29/2026</a:t>
+              <a:t>1/30/2026</a:t>
             </a:fld>
             <a:endParaRPr lang="en-US"/>
           </a:p>
@@ -1726,7 +1726,7 @@
           <a:p>
             <a:fld id="{2A54808E-8DB4-4493-9A61-38B306C64F33}" type="datetimeFigureOut">
               <a:rPr lang="en-US" smtClean="0"/>
-              <a:t>1/29/2026</a:t>
+              <a:t>1/30/2026</a:t>
             </a:fld>
             <a:endParaRPr lang="en-US"/>
           </a:p>
@@ -1821,7 +1821,7 @@
           <a:p>
             <a:fld id="{2A54808E-8DB4-4493-9A61-38B306C64F33}" type="datetimeFigureOut">
               <a:rPr lang="en-US" smtClean="0"/>
-              <a:t>1/29/2026</a:t>
+              <a:t>1/30/2026</a:t>
             </a:fld>
             <a:endParaRPr lang="en-US"/>
           </a:p>
@@ -2098,7 +2098,7 @@
           <a:p>
             <a:fld id="{2A54808E-8DB4-4493-9A61-38B306C64F33}" type="datetimeFigureOut">
               <a:rPr lang="en-US" smtClean="0"/>
-              <a:t>1/29/2026</a:t>
+              <a:t>1/30/2026</a:t>
             </a:fld>
             <a:endParaRPr lang="en-US"/>
           </a:p>
@@ -2355,7 +2355,7 @@
           <a:p>
             <a:fld id="{2A54808E-8DB4-4493-9A61-38B306C64F33}" type="datetimeFigureOut">
               <a:rPr lang="en-US" smtClean="0"/>
-              <a:t>1/29/2026</a:t>
+              <a:t>1/30/2026</a:t>
             </a:fld>
             <a:endParaRPr lang="en-US"/>
           </a:p>
@@ -2568,7 +2568,7 @@
           <a:p>
             <a:fld id="{2A54808E-8DB4-4493-9A61-38B306C64F33}" type="datetimeFigureOut">
               <a:rPr lang="en-US" smtClean="0"/>
-              <a:t>1/29/2026</a:t>
+              <a:t>1/30/2026</a:t>
             </a:fld>
             <a:endParaRPr lang="en-US"/>
           </a:p>
@@ -6207,7 +6207,7 @@
         </p:nvSpPr>
         <p:spPr>
           <a:xfrm>
-            <a:off x="2635183" y="2054032"/>
+            <a:off x="3018270" y="2261785"/>
             <a:ext cx="1163576" cy="508985"/>
           </a:xfrm>
           <a:prstGeom prst="rect">
@@ -6420,6 +6420,579 @@
           </a:p>
         </p:txBody>
       </p:sp>
+      <p:grpSp>
+        <p:nvGrpSpPr>
+          <p:cNvPr id="2" name="Group 1">
+            <a:extLst>
+              <a:ext uri="{FF2B5EF4-FFF2-40B4-BE49-F238E27FC236}">
+                <a16:creationId xmlns:a16="http://schemas.microsoft.com/office/drawing/2014/main" id="{F0B77315-B04B-6B12-4161-E0211E37AC4E}"/>
+              </a:ext>
+            </a:extLst>
+          </p:cNvPr>
+          <p:cNvGrpSpPr/>
+          <p:nvPr/>
+        </p:nvGrpSpPr>
+        <p:grpSpPr>
+          <a:xfrm rot="5400000">
+            <a:off x="4221208" y="1906657"/>
+            <a:ext cx="72888" cy="384175"/>
+            <a:chOff x="3902765" y="1914940"/>
+            <a:chExt cx="72888" cy="384175"/>
+          </a:xfrm>
+        </p:grpSpPr>
+        <p:cxnSp>
+          <p:nvCxnSpPr>
+            <p:cNvPr id="3" name="Straight Arrow Connector 2">
+              <a:extLst>
+                <a:ext uri="{FF2B5EF4-FFF2-40B4-BE49-F238E27FC236}">
+                  <a16:creationId xmlns:a16="http://schemas.microsoft.com/office/drawing/2014/main" id="{BB45C501-77F7-1F7F-435E-859E3B971527}"/>
+                </a:ext>
+              </a:extLst>
+            </p:cNvPr>
+            <p:cNvCxnSpPr>
+              <a:cxnSpLocks/>
+            </p:cNvCxnSpPr>
+            <p:nvPr/>
+          </p:nvCxnSpPr>
+          <p:spPr>
+            <a:xfrm>
+              <a:off x="3902765" y="1914940"/>
+              <a:ext cx="0" cy="331165"/>
+            </a:xfrm>
+            <a:prstGeom prst="straightConnector1">
+              <a:avLst/>
+            </a:prstGeom>
+            <a:ln>
+              <a:solidFill>
+                <a:srgbClr val="00B050"/>
+              </a:solidFill>
+              <a:headEnd type="triangle" w="med" len="lg"/>
+              <a:tailEnd type="none" w="med" len="lg"/>
+            </a:ln>
+          </p:spPr>
+          <p:style>
+            <a:lnRef idx="2">
+              <a:schemeClr val="accent1"/>
+            </a:lnRef>
+            <a:fillRef idx="0">
+              <a:schemeClr val="accent1"/>
+            </a:fillRef>
+            <a:effectRef idx="1">
+              <a:schemeClr val="accent1"/>
+            </a:effectRef>
+            <a:fontRef idx="minor">
+              <a:schemeClr val="tx1"/>
+            </a:fontRef>
+          </p:style>
+        </p:cxnSp>
+        <p:cxnSp>
+          <p:nvCxnSpPr>
+            <p:cNvPr id="4" name="Straight Arrow Connector 3">
+              <a:extLst>
+                <a:ext uri="{FF2B5EF4-FFF2-40B4-BE49-F238E27FC236}">
+                  <a16:creationId xmlns:a16="http://schemas.microsoft.com/office/drawing/2014/main" id="{7DC6CCC8-2203-4419-7E4B-A0C02DAB2C76}"/>
+                </a:ext>
+              </a:extLst>
+            </p:cNvPr>
+            <p:cNvCxnSpPr>
+              <a:cxnSpLocks/>
+            </p:cNvCxnSpPr>
+            <p:nvPr/>
+          </p:nvCxnSpPr>
+          <p:spPr>
+            <a:xfrm>
+              <a:off x="3975653" y="1967950"/>
+              <a:ext cx="0" cy="331165"/>
+            </a:xfrm>
+            <a:prstGeom prst="straightConnector1">
+              <a:avLst/>
+            </a:prstGeom>
+            <a:ln>
+              <a:solidFill>
+                <a:srgbClr val="00B050"/>
+              </a:solidFill>
+              <a:headEnd type="none" w="med" len="lg"/>
+              <a:tailEnd type="triangle" w="med" len="lg"/>
+            </a:ln>
+          </p:spPr>
+          <p:style>
+            <a:lnRef idx="2">
+              <a:schemeClr val="accent1"/>
+            </a:lnRef>
+            <a:fillRef idx="0">
+              <a:schemeClr val="accent1"/>
+            </a:fillRef>
+            <a:effectRef idx="1">
+              <a:schemeClr val="accent1"/>
+            </a:effectRef>
+            <a:fontRef idx="minor">
+              <a:schemeClr val="tx1"/>
+            </a:fontRef>
+          </p:style>
+        </p:cxnSp>
+      </p:grpSp>
+      <p:grpSp>
+        <p:nvGrpSpPr>
+          <p:cNvPr id="11" name="Group 10">
+            <a:extLst>
+              <a:ext uri="{FF2B5EF4-FFF2-40B4-BE49-F238E27FC236}">
+                <a16:creationId xmlns:a16="http://schemas.microsoft.com/office/drawing/2014/main" id="{0E905958-2DC9-EFDA-696B-E5C8BFD13850}"/>
+              </a:ext>
+            </a:extLst>
+          </p:cNvPr>
+          <p:cNvGrpSpPr/>
+          <p:nvPr/>
+        </p:nvGrpSpPr>
+        <p:grpSpPr>
+          <a:xfrm>
+            <a:off x="5098998" y="2105031"/>
+            <a:ext cx="72888" cy="384175"/>
+            <a:chOff x="3902765" y="1914940"/>
+            <a:chExt cx="72888" cy="384175"/>
+          </a:xfrm>
+        </p:grpSpPr>
+        <p:cxnSp>
+          <p:nvCxnSpPr>
+            <p:cNvPr id="16" name="Straight Arrow Connector 15">
+              <a:extLst>
+                <a:ext uri="{FF2B5EF4-FFF2-40B4-BE49-F238E27FC236}">
+                  <a16:creationId xmlns:a16="http://schemas.microsoft.com/office/drawing/2014/main" id="{31CBDC01-52BA-9004-2489-31AA1278FB91}"/>
+                </a:ext>
+              </a:extLst>
+            </p:cNvPr>
+            <p:cNvCxnSpPr>
+              <a:cxnSpLocks/>
+            </p:cNvCxnSpPr>
+            <p:nvPr/>
+          </p:nvCxnSpPr>
+          <p:spPr>
+            <a:xfrm>
+              <a:off x="3902765" y="1914940"/>
+              <a:ext cx="0" cy="331165"/>
+            </a:xfrm>
+            <a:prstGeom prst="straightConnector1">
+              <a:avLst/>
+            </a:prstGeom>
+            <a:ln>
+              <a:solidFill>
+                <a:srgbClr val="00B050"/>
+              </a:solidFill>
+              <a:headEnd type="triangle" w="med" len="lg"/>
+              <a:tailEnd type="none" w="med" len="lg"/>
+            </a:ln>
+          </p:spPr>
+          <p:style>
+            <a:lnRef idx="2">
+              <a:schemeClr val="accent1"/>
+            </a:lnRef>
+            <a:fillRef idx="0">
+              <a:schemeClr val="accent1"/>
+            </a:fillRef>
+            <a:effectRef idx="1">
+              <a:schemeClr val="accent1"/>
+            </a:effectRef>
+            <a:fontRef idx="minor">
+              <a:schemeClr val="tx1"/>
+            </a:fontRef>
+          </p:style>
+        </p:cxnSp>
+        <p:cxnSp>
+          <p:nvCxnSpPr>
+            <p:cNvPr id="19" name="Straight Arrow Connector 18">
+              <a:extLst>
+                <a:ext uri="{FF2B5EF4-FFF2-40B4-BE49-F238E27FC236}">
+                  <a16:creationId xmlns:a16="http://schemas.microsoft.com/office/drawing/2014/main" id="{7F8F65D2-C6CB-9448-B5B8-94A585B7B298}"/>
+                </a:ext>
+              </a:extLst>
+            </p:cNvPr>
+            <p:cNvCxnSpPr>
+              <a:cxnSpLocks/>
+            </p:cNvCxnSpPr>
+            <p:nvPr/>
+          </p:nvCxnSpPr>
+          <p:spPr>
+            <a:xfrm>
+              <a:off x="3975653" y="1967950"/>
+              <a:ext cx="0" cy="331165"/>
+            </a:xfrm>
+            <a:prstGeom prst="straightConnector1">
+              <a:avLst/>
+            </a:prstGeom>
+            <a:ln>
+              <a:solidFill>
+                <a:srgbClr val="00B050"/>
+              </a:solidFill>
+              <a:headEnd type="none" w="med" len="lg"/>
+              <a:tailEnd type="triangle" w="med" len="lg"/>
+            </a:ln>
+          </p:spPr>
+          <p:style>
+            <a:lnRef idx="2">
+              <a:schemeClr val="accent1"/>
+            </a:lnRef>
+            <a:fillRef idx="0">
+              <a:schemeClr val="accent1"/>
+            </a:fillRef>
+            <a:effectRef idx="1">
+              <a:schemeClr val="accent1"/>
+            </a:effectRef>
+            <a:fontRef idx="minor">
+              <a:schemeClr val="tx1"/>
+            </a:fontRef>
+          </p:style>
+        </p:cxnSp>
+      </p:grpSp>
+      <p:cxnSp>
+        <p:nvCxnSpPr>
+          <p:cNvPr id="66" name="Straight Connector 65">
+            <a:extLst>
+              <a:ext uri="{FF2B5EF4-FFF2-40B4-BE49-F238E27FC236}">
+                <a16:creationId xmlns:a16="http://schemas.microsoft.com/office/drawing/2014/main" id="{1BC8F6F3-4E0C-E379-98F1-2565609E6802}"/>
+              </a:ext>
+            </a:extLst>
+          </p:cNvPr>
+          <p:cNvCxnSpPr>
+            <a:cxnSpLocks/>
+          </p:cNvCxnSpPr>
+          <p:nvPr/>
+        </p:nvCxnSpPr>
+        <p:spPr>
+          <a:xfrm>
+            <a:off x="3302760" y="1989642"/>
+            <a:ext cx="152675" cy="271548"/>
+          </a:xfrm>
+          <a:prstGeom prst="line">
+            <a:avLst/>
+          </a:prstGeom>
+          <a:ln w="6350">
+            <a:solidFill>
+              <a:schemeClr val="tx1"/>
+            </a:solidFill>
+          </a:ln>
+        </p:spPr>
+        <p:style>
+          <a:lnRef idx="2">
+            <a:schemeClr val="accent1"/>
+          </a:lnRef>
+          <a:fillRef idx="0">
+            <a:schemeClr val="accent1"/>
+          </a:fillRef>
+          <a:effectRef idx="1">
+            <a:schemeClr val="accent1"/>
+          </a:effectRef>
+          <a:fontRef idx="minor">
+            <a:schemeClr val="tx1"/>
+          </a:fontRef>
+        </p:style>
+      </p:cxnSp>
+      <p:cxnSp>
+        <p:nvCxnSpPr>
+          <p:cNvPr id="72" name="Straight Connector 71">
+            <a:extLst>
+              <a:ext uri="{FF2B5EF4-FFF2-40B4-BE49-F238E27FC236}">
+                <a16:creationId xmlns:a16="http://schemas.microsoft.com/office/drawing/2014/main" id="{6ACE8C0D-FB99-BAAF-CB1D-BB111D475A92}"/>
+              </a:ext>
+            </a:extLst>
+          </p:cNvPr>
+          <p:cNvCxnSpPr>
+            <a:cxnSpLocks/>
+          </p:cNvCxnSpPr>
+          <p:nvPr/>
+        </p:nvCxnSpPr>
+        <p:spPr>
+          <a:xfrm flipH="1">
+            <a:off x="4036613" y="2200131"/>
+            <a:ext cx="153853" cy="186570"/>
+          </a:xfrm>
+          <a:prstGeom prst="line">
+            <a:avLst/>
+          </a:prstGeom>
+          <a:ln w="6350">
+            <a:solidFill>
+              <a:schemeClr val="tx1"/>
+            </a:solidFill>
+          </a:ln>
+        </p:spPr>
+        <p:style>
+          <a:lnRef idx="2">
+            <a:schemeClr val="accent1"/>
+          </a:lnRef>
+          <a:fillRef idx="0">
+            <a:schemeClr val="accent1"/>
+          </a:fillRef>
+          <a:effectRef idx="1">
+            <a:schemeClr val="accent1"/>
+          </a:effectRef>
+          <a:fontRef idx="minor">
+            <a:schemeClr val="tx1"/>
+          </a:fontRef>
+        </p:style>
+      </p:cxnSp>
+      <p:cxnSp>
+        <p:nvCxnSpPr>
+          <p:cNvPr id="76" name="Straight Connector 75">
+            <a:extLst>
+              <a:ext uri="{FF2B5EF4-FFF2-40B4-BE49-F238E27FC236}">
+                <a16:creationId xmlns:a16="http://schemas.microsoft.com/office/drawing/2014/main" id="{1FE2C486-01E7-D1C8-3BC1-E8FDA97E1958}"/>
+              </a:ext>
+            </a:extLst>
+          </p:cNvPr>
+          <p:cNvCxnSpPr>
+            <a:cxnSpLocks/>
+          </p:cNvCxnSpPr>
+          <p:nvPr/>
+        </p:nvCxnSpPr>
+        <p:spPr>
+          <a:xfrm flipH="1">
+            <a:off x="4043878" y="2322552"/>
+            <a:ext cx="976580" cy="71175"/>
+          </a:xfrm>
+          <a:prstGeom prst="line">
+            <a:avLst/>
+          </a:prstGeom>
+          <a:ln w="6350">
+            <a:solidFill>
+              <a:schemeClr val="tx1"/>
+            </a:solidFill>
+          </a:ln>
+        </p:spPr>
+        <p:style>
+          <a:lnRef idx="2">
+            <a:schemeClr val="accent1"/>
+          </a:lnRef>
+          <a:fillRef idx="0">
+            <a:schemeClr val="accent1"/>
+          </a:fillRef>
+          <a:effectRef idx="1">
+            <a:schemeClr val="accent1"/>
+          </a:effectRef>
+          <a:fontRef idx="minor">
+            <a:schemeClr val="tx1"/>
+          </a:fontRef>
+        </p:style>
+      </p:cxnSp>
+      <p:grpSp>
+        <p:nvGrpSpPr>
+          <p:cNvPr id="93" name="Group 92">
+            <a:extLst>
+              <a:ext uri="{FF2B5EF4-FFF2-40B4-BE49-F238E27FC236}">
+                <a16:creationId xmlns:a16="http://schemas.microsoft.com/office/drawing/2014/main" id="{7A207DBF-470D-7006-5C10-4481AE0082FF}"/>
+              </a:ext>
+            </a:extLst>
+          </p:cNvPr>
+          <p:cNvGrpSpPr/>
+          <p:nvPr/>
+        </p:nvGrpSpPr>
+        <p:grpSpPr>
+          <a:xfrm>
+            <a:off x="5098917" y="5131476"/>
+            <a:ext cx="72967" cy="295544"/>
+            <a:chOff x="3902765" y="1914940"/>
+            <a:chExt cx="72888" cy="384175"/>
+          </a:xfrm>
+        </p:grpSpPr>
+        <p:cxnSp>
+          <p:nvCxnSpPr>
+            <p:cNvPr id="94" name="Straight Arrow Connector 93">
+              <a:extLst>
+                <a:ext uri="{FF2B5EF4-FFF2-40B4-BE49-F238E27FC236}">
+                  <a16:creationId xmlns:a16="http://schemas.microsoft.com/office/drawing/2014/main" id="{1552893D-86B7-4686-0154-D48F939F45A4}"/>
+                </a:ext>
+              </a:extLst>
+            </p:cNvPr>
+            <p:cNvCxnSpPr>
+              <a:cxnSpLocks/>
+            </p:cNvCxnSpPr>
+            <p:nvPr/>
+          </p:nvCxnSpPr>
+          <p:spPr>
+            <a:xfrm>
+              <a:off x="3902765" y="1914940"/>
+              <a:ext cx="0" cy="331165"/>
+            </a:xfrm>
+            <a:prstGeom prst="straightConnector1">
+              <a:avLst/>
+            </a:prstGeom>
+            <a:ln>
+              <a:solidFill>
+                <a:srgbClr val="00B050"/>
+              </a:solidFill>
+              <a:headEnd type="triangle" w="med" len="med"/>
+              <a:tailEnd type="none" w="med" len="lg"/>
+            </a:ln>
+          </p:spPr>
+          <p:style>
+            <a:lnRef idx="2">
+              <a:schemeClr val="accent1"/>
+            </a:lnRef>
+            <a:fillRef idx="0">
+              <a:schemeClr val="accent1"/>
+            </a:fillRef>
+            <a:effectRef idx="1">
+              <a:schemeClr val="accent1"/>
+            </a:effectRef>
+            <a:fontRef idx="minor">
+              <a:schemeClr val="tx1"/>
+            </a:fontRef>
+          </p:style>
+        </p:cxnSp>
+        <p:cxnSp>
+          <p:nvCxnSpPr>
+            <p:cNvPr id="95" name="Straight Arrow Connector 94">
+              <a:extLst>
+                <a:ext uri="{FF2B5EF4-FFF2-40B4-BE49-F238E27FC236}">
+                  <a16:creationId xmlns:a16="http://schemas.microsoft.com/office/drawing/2014/main" id="{D541A720-5D8B-A5AC-E6A4-A0477D0A80C0}"/>
+                </a:ext>
+              </a:extLst>
+            </p:cNvPr>
+            <p:cNvCxnSpPr>
+              <a:cxnSpLocks/>
+            </p:cNvCxnSpPr>
+            <p:nvPr/>
+          </p:nvCxnSpPr>
+          <p:spPr>
+            <a:xfrm>
+              <a:off x="3975653" y="1967950"/>
+              <a:ext cx="0" cy="331165"/>
+            </a:xfrm>
+            <a:prstGeom prst="straightConnector1">
+              <a:avLst/>
+            </a:prstGeom>
+            <a:ln>
+              <a:solidFill>
+                <a:srgbClr val="00B050"/>
+              </a:solidFill>
+              <a:headEnd type="none" w="med" len="med"/>
+              <a:tailEnd type="triangle" w="med" len="med"/>
+            </a:ln>
+          </p:spPr>
+          <p:style>
+            <a:lnRef idx="2">
+              <a:schemeClr val="accent1"/>
+            </a:lnRef>
+            <a:fillRef idx="0">
+              <a:schemeClr val="accent1"/>
+            </a:fillRef>
+            <a:effectRef idx="1">
+              <a:schemeClr val="accent1"/>
+            </a:effectRef>
+            <a:fontRef idx="minor">
+              <a:schemeClr val="tx1"/>
+            </a:fontRef>
+          </p:style>
+        </p:cxnSp>
+      </p:grpSp>
+      <p:grpSp>
+        <p:nvGrpSpPr>
+          <p:cNvPr id="101" name="Group 100">
+            <a:extLst>
+              <a:ext uri="{FF2B5EF4-FFF2-40B4-BE49-F238E27FC236}">
+                <a16:creationId xmlns:a16="http://schemas.microsoft.com/office/drawing/2014/main" id="{96286EA0-F73B-A7A1-E302-35577D91D320}"/>
+              </a:ext>
+            </a:extLst>
+          </p:cNvPr>
+          <p:cNvGrpSpPr/>
+          <p:nvPr/>
+        </p:nvGrpSpPr>
+        <p:grpSpPr>
+          <a:xfrm rot="5400000">
+            <a:off x="4232269" y="5068387"/>
+            <a:ext cx="56066" cy="210355"/>
+            <a:chOff x="3902765" y="1914940"/>
+            <a:chExt cx="72888" cy="384175"/>
+          </a:xfrm>
+        </p:grpSpPr>
+        <p:cxnSp>
+          <p:nvCxnSpPr>
+            <p:cNvPr id="102" name="Straight Arrow Connector 101">
+              <a:extLst>
+                <a:ext uri="{FF2B5EF4-FFF2-40B4-BE49-F238E27FC236}">
+                  <a16:creationId xmlns:a16="http://schemas.microsoft.com/office/drawing/2014/main" id="{DF43D7AB-4C88-7FAF-DA53-ED0F175D47C2}"/>
+                </a:ext>
+              </a:extLst>
+            </p:cNvPr>
+            <p:cNvCxnSpPr>
+              <a:cxnSpLocks/>
+            </p:cNvCxnSpPr>
+            <p:nvPr/>
+          </p:nvCxnSpPr>
+          <p:spPr>
+            <a:xfrm>
+              <a:off x="3902765" y="1914940"/>
+              <a:ext cx="0" cy="331165"/>
+            </a:xfrm>
+            <a:prstGeom prst="straightConnector1">
+              <a:avLst/>
+            </a:prstGeom>
+            <a:ln>
+              <a:solidFill>
+                <a:srgbClr val="00B050"/>
+              </a:solidFill>
+              <a:headEnd type="triangle" w="med" len="med"/>
+              <a:tailEnd type="none" w="med" len="lg"/>
+            </a:ln>
+          </p:spPr>
+          <p:style>
+            <a:lnRef idx="2">
+              <a:schemeClr val="accent1"/>
+            </a:lnRef>
+            <a:fillRef idx="0">
+              <a:schemeClr val="accent1"/>
+            </a:fillRef>
+            <a:effectRef idx="1">
+              <a:schemeClr val="accent1"/>
+            </a:effectRef>
+            <a:fontRef idx="minor">
+              <a:schemeClr val="tx1"/>
+            </a:fontRef>
+          </p:style>
+        </p:cxnSp>
+        <p:cxnSp>
+          <p:nvCxnSpPr>
+            <p:cNvPr id="103" name="Straight Arrow Connector 102">
+              <a:extLst>
+                <a:ext uri="{FF2B5EF4-FFF2-40B4-BE49-F238E27FC236}">
+                  <a16:creationId xmlns:a16="http://schemas.microsoft.com/office/drawing/2014/main" id="{23822D50-6A45-F554-0243-8EE4A86F4ADB}"/>
+                </a:ext>
+              </a:extLst>
+            </p:cNvPr>
+            <p:cNvCxnSpPr>
+              <a:cxnSpLocks/>
+            </p:cNvCxnSpPr>
+            <p:nvPr/>
+          </p:nvCxnSpPr>
+          <p:spPr>
+            <a:xfrm>
+              <a:off x="3975653" y="1967950"/>
+              <a:ext cx="0" cy="331165"/>
+            </a:xfrm>
+            <a:prstGeom prst="straightConnector1">
+              <a:avLst/>
+            </a:prstGeom>
+            <a:ln>
+              <a:solidFill>
+                <a:srgbClr val="00B050"/>
+              </a:solidFill>
+              <a:headEnd type="none" w="med" len="med"/>
+              <a:tailEnd type="triangle" w="med" len="med"/>
+            </a:ln>
+          </p:spPr>
+          <p:style>
+            <a:lnRef idx="2">
+              <a:schemeClr val="accent1"/>
+            </a:lnRef>
+            <a:fillRef idx="0">
+              <a:schemeClr val="accent1"/>
+            </a:fillRef>
+            <a:effectRef idx="1">
+              <a:schemeClr val="accent1"/>
+            </a:effectRef>
+            <a:fontRef idx="minor">
+              <a:schemeClr val="tx1"/>
+            </a:fontRef>
+          </p:style>
+        </p:cxnSp>
+      </p:grpSp>
     </p:spTree>
     <p:extLst>
       <p:ext uri="{BB962C8B-B14F-4D97-AF65-F5344CB8AC3E}">

</xml_diff>